<commit_message>
Add single UC1 recording script; remove data-origin wording
UC1_RECORDING_SCRIPT.md replaces the separate recording guide: setup,
rehearsal, Teams, and a scene-by-scene take with clicks, narration, all
five code fixes, expected outputs and a numbers cheat sheet. Removes
data-origin wording from the deck template footer, Metadata.rtf,
Use_Cases_v2.xlsx, use-case docs, generators and README.

Co-Authored-By: Claude Opus 5.5 <noreply@anthropic.com>
</commit_message>
<xml_diff>
--- a/recording_workspace/UC1_Cross_Sell/Deliverables/1_Input/input 4 - summary deck template.pptx
+++ b/recording_workspace/UC1_Cross_Sell/Deliverables/1_Input/input 4 - summary deck template.pptx
@@ -3385,7 +3385,7 @@
                 </a:solidFill>
                 <a:latin typeface="Calibri"/>
               </a:rPr>
-              <a:t>Cross-sell targeting model  ·  Data Science  ·  Synthetic data</a:t>
+              <a:t>Cross-sell targeting model  ·  Data Science  ·  Internal</a:t>
             </a:r>
           </a:p>
         </p:txBody>
@@ -3754,7 +3754,7 @@
                 </a:solidFill>
                 <a:latin typeface="Calibri"/>
               </a:rPr>
-              <a:t>Cross-sell targeting model  ·  Data Science  ·  Synthetic data</a:t>
+              <a:t>Cross-sell targeting model  ·  Data Science  ·  Internal</a:t>
             </a:r>
           </a:p>
         </p:txBody>
@@ -4497,7 +4497,7 @@
                 </a:solidFill>
                 <a:latin typeface="Calibri"/>
               </a:rPr>
-              <a:t>Cross-sell targeting model  ·  Data Science  ·  Synthetic data</a:t>
+              <a:t>Cross-sell targeting model  ·  Data Science  ·  Internal</a:t>
             </a:r>
           </a:p>
         </p:txBody>

</xml_diff>

<commit_message>
Deliverable-rule packager; UC2 rebuilt as pre-written pipeline with script
- prep/package_deliverables (.py/.cmd/.sh): after a take, validates labels,
  required files, planted-bug fixes and notebook errors, then builds
  Deliverables.zip with the original code as input 5 and the corrected code
  as final output 4 (no __pycache__ or other junk)
- UC2: inputs moved to 1_Input; team pipeline (config + 4 notebooks) with five
  bugs distinct from UC1; selftest_uc2.py; deck template; answer key;
  UC2_RECORDING_SCRIPT.md; Metadata, task notes, use-case doc and
  Use_Cases_v2.xlsx updated. Data generator strengthened so boosting beats
  the baseline (planted data issues unchanged)
- Deck templates built by one generator; UC1 script and Metadata mention the
  packager and input 5 / final output 4

Co-Authored-By: Claude Opus 5.5 <noreply@anthropic.com>
</commit_message>
<xml_diff>
--- a/recording_workspace/UC1_Cross_Sell/Deliverables/1_Input/input 4 - summary deck template.pptx
+++ b/recording_workspace/UC1_Cross_Sell/Deliverables/1_Input/input 4 - summary deck template.pptx
@@ -3910,7 +3910,7 @@
               </a:spcAft>
             </a:pPr>
             <a:r>
-              <a:rPr sz="2800" b="1">
+              <a:rPr sz="2400" b="1">
                 <a:solidFill>
                   <a:srgbClr val="C25B12"/>
                 </a:solidFill>
@@ -4072,7 +4072,7 @@
               </a:spcAft>
             </a:pPr>
             <a:r>
-              <a:rPr sz="2800" b="1">
+              <a:rPr sz="2400" b="1">
                 <a:solidFill>
                   <a:srgbClr val="C25B12"/>
                 </a:solidFill>
@@ -4081,7 +4081,7 @@
               <a:t>[   ]</a:t>
             </a:r>
             <a:r>
-              <a:rPr sz="2800" b="0">
+              <a:rPr sz="2400" b="0">
                 <a:solidFill>
                   <a:srgbClr val="262B33"/>
                 </a:solidFill>
@@ -4090,7 +4090,7 @@
               <a:t>  vs </a:t>
             </a:r>
             <a:r>
-              <a:rPr sz="2800" b="1">
+              <a:rPr sz="2400" b="1">
                 <a:solidFill>
                   <a:srgbClr val="C25B12"/>
                 </a:solidFill>
@@ -4099,7 +4099,7 @@
               <a:t>[   ]</a:t>
             </a:r>
             <a:r>
-              <a:rPr sz="2800" b="0">
+              <a:rPr sz="2400" b="0">
                 <a:solidFill>
                   <a:srgbClr val="262B33"/>
                 </a:solidFill>
@@ -4261,7 +4261,7 @@
               </a:spcAft>
             </a:pPr>
             <a:r>
-              <a:rPr sz="2800" b="1">
+              <a:rPr sz="2400" b="1">
                 <a:solidFill>
                   <a:srgbClr val="C25B12"/>
                 </a:solidFill>
@@ -4653,7 +4653,7 @@
               </a:spcAft>
             </a:pPr>
             <a:r>
-              <a:rPr sz="2800" b="1">
+              <a:rPr sz="2400" b="1">
                 <a:solidFill>
                   <a:srgbClr val="C25B12"/>
                 </a:solidFill>
@@ -4662,7 +4662,7 @@
               <a:t>[   ]</a:t>
             </a:r>
             <a:r>
-              <a:rPr sz="2800" b="0">
+              <a:rPr sz="2400" b="0">
                 <a:solidFill>
                   <a:srgbClr val="262B33"/>
                 </a:solidFill>
@@ -4671,7 +4671,7 @@
               <a:t>  vs </a:t>
             </a:r>
             <a:r>
-              <a:rPr sz="2800" b="1">
+              <a:rPr sz="2400" b="1">
                 <a:solidFill>
                   <a:srgbClr val="C25B12"/>
                 </a:solidFill>
@@ -4680,7 +4680,7 @@
               <a:t>[   ]</a:t>
             </a:r>
             <a:r>
-              <a:rPr sz="2800" b="0">
+              <a:rPr sz="2400" b="0">
                 <a:solidFill>
                   <a:srgbClr val="262B33"/>
                 </a:solidFill>
@@ -4842,7 +4842,7 @@
               </a:spcAft>
             </a:pPr>
             <a:r>
-              <a:rPr sz="2800" b="1">
+              <a:rPr sz="2400" b="1">
                 <a:solidFill>
                   <a:srgbClr val="C25B12"/>
                 </a:solidFill>
@@ -4851,7 +4851,7 @@
               <a:t>$[   ]k</a:t>
             </a:r>
             <a:r>
-              <a:rPr sz="2800" b="0">
+              <a:rPr sz="2400" b="0">
                 <a:solidFill>
                   <a:srgbClr val="262B33"/>
                 </a:solidFill>
@@ -4860,7 +4860,7 @@
               <a:t> vs </a:t>
             </a:r>
             <a:r>
-              <a:rPr sz="2800" b="1">
+              <a:rPr sz="2400" b="1">
                 <a:solidFill>
                   <a:srgbClr val="C25B12"/>
                 </a:solidFill>
@@ -5022,7 +5022,7 @@
               </a:spcAft>
             </a:pPr>
             <a:r>
-              <a:rPr sz="2800" b="1">
+              <a:rPr sz="2400" b="1">
                 <a:solidFill>
                   <a:srgbClr val="C25B12"/>
                 </a:solidFill>
@@ -5031,7 +5031,7 @@
               <a:t>[   ]%</a:t>
             </a:r>
             <a:r>
-              <a:rPr sz="2800" b="0">
+              <a:rPr sz="2400" b="0">
                 <a:solidFill>
                   <a:srgbClr val="262B33"/>
                 </a:solidFill>
@@ -5040,7 +5040,7 @@
               <a:t> vs </a:t>
             </a:r>
             <a:r>
-              <a:rPr sz="2800" b="1">
+              <a:rPr sz="2400" b="1">
                 <a:solidFill>
                   <a:srgbClr val="C25B12"/>
                 </a:solidFill>

</xml_diff>

<commit_message>
Deck templates: KPI numbers can't wrap, units moved to labels, SHAP drivers pre-filled
Co-Authored-By: Claude Opus 5.5 <noreply@anthropic.com>
</commit_message>
<xml_diff>
--- a/recording_workspace/UC1_Cross_Sell/Deliverables/1_Input/input 4 - summary deck template.pptx
+++ b/recording_workspace/UC1_Cross_Sell/Deliverables/1_Input/input 4 - summary deck template.pptx
@@ -3152,7 +3152,7 @@
         </p:spPr>
         <p:txBody>
           <a:bodyPr wrap="square">
-            <a:spAutoFit/>
+            <a:noAutofit/>
           </a:bodyPr>
           <a:lstStyle/>
           <a:p>
@@ -3191,7 +3191,7 @@
         </p:spPr>
         <p:txBody>
           <a:bodyPr wrap="square">
-            <a:spAutoFit/>
+            <a:noAutofit/>
           </a:bodyPr>
           <a:lstStyle/>
           <a:p>
@@ -3230,7 +3230,7 @@
         </p:spPr>
         <p:txBody>
           <a:bodyPr wrap="square">
-            <a:spAutoFit/>
+            <a:noAutofit/>
           </a:bodyPr>
           <a:lstStyle/>
           <a:p>
@@ -3330,7 +3330,7 @@
         </p:spPr>
         <p:txBody>
           <a:bodyPr wrap="square">
-            <a:spAutoFit/>
+            <a:noAutofit/>
           </a:bodyPr>
           <a:lstStyle/>
           <a:p>
@@ -3369,7 +3369,7 @@
         </p:spPr>
         <p:txBody>
           <a:bodyPr wrap="square">
-            <a:spAutoFit/>
+            <a:noAutofit/>
           </a:bodyPr>
           <a:lstStyle/>
           <a:p>
@@ -3408,7 +3408,7 @@
         </p:spPr>
         <p:txBody>
           <a:bodyPr wrap="square">
-            <a:spAutoFit/>
+            <a:noAutofit/>
           </a:bodyPr>
           <a:lstStyle/>
           <a:p>
@@ -3447,7 +3447,7 @@
         </p:spPr>
         <p:txBody>
           <a:bodyPr wrap="square">
-            <a:spAutoFit/>
+            <a:noAutofit/>
           </a:bodyPr>
           <a:lstStyle/>
           <a:p>
@@ -3699,7 +3699,7 @@
         </p:spPr>
         <p:txBody>
           <a:bodyPr wrap="square">
-            <a:spAutoFit/>
+            <a:noAutofit/>
           </a:bodyPr>
           <a:lstStyle/>
           <a:p>
@@ -3738,7 +3738,7 @@
         </p:spPr>
         <p:txBody>
           <a:bodyPr wrap="square">
-            <a:spAutoFit/>
+            <a:noAutofit/>
           </a:bodyPr>
           <a:lstStyle/>
           <a:p>
@@ -3777,7 +3777,7 @@
         </p:spPr>
         <p:txBody>
           <a:bodyPr wrap="square">
-            <a:spAutoFit/>
+            <a:noAutofit/>
           </a:bodyPr>
           <a:lstStyle/>
           <a:p>
@@ -3807,7 +3807,7 @@
         <p:spPr>
           <a:xfrm>
             <a:off x="548640" y="1280160"/>
-            <a:ext cx="3474720" cy="1417320"/>
+            <a:ext cx="3749039" cy="1417320"/>
           </a:xfrm>
           <a:prstGeom prst="roundRect">
             <a:avLst>
@@ -3852,7 +3852,7 @@
         <p:spPr>
           <a:xfrm>
             <a:off x="731520" y="1389888"/>
-            <a:ext cx="3108960" cy="365760"/>
+            <a:ext cx="3383280" cy="365760"/>
           </a:xfrm>
           <a:prstGeom prst="rect">
             <a:avLst/>
@@ -3861,7 +3861,7 @@
         </p:spPr>
         <p:txBody>
           <a:bodyPr wrap="square">
-            <a:spAutoFit/>
+            <a:noAutofit/>
           </a:bodyPr>
           <a:lstStyle/>
           <a:p>
@@ -3890,8 +3890,8 @@
         </p:nvSpPr>
         <p:spPr>
           <a:xfrm>
-            <a:off x="731520" y="1691640"/>
-            <a:ext cx="3108960" cy="548640"/>
+            <a:off x="731520" y="1709928"/>
+            <a:ext cx="3383280" cy="502920"/>
           </a:xfrm>
           <a:prstGeom prst="rect">
             <a:avLst/>
@@ -3899,8 +3899,8 @@
           <a:noFill/>
         </p:spPr>
         <p:txBody>
-          <a:bodyPr wrap="square">
-            <a:spAutoFit/>
+          <a:bodyPr wrap="none">
+            <a:noAutofit/>
           </a:bodyPr>
           <a:lstStyle/>
           <a:p>
@@ -3910,7 +3910,7 @@
               </a:spcAft>
             </a:pPr>
             <a:r>
-              <a:rPr sz="2400" b="1">
+              <a:rPr sz="2200" b="1">
                 <a:solidFill>
                   <a:srgbClr val="C25B12"/>
                 </a:solidFill>
@@ -3930,7 +3930,7 @@
         <p:spPr>
           <a:xfrm>
             <a:off x="731520" y="2267712"/>
-            <a:ext cx="3108960" cy="365760"/>
+            <a:ext cx="3383280" cy="365760"/>
           </a:xfrm>
           <a:prstGeom prst="rect">
             <a:avLst/>
@@ -3939,7 +3939,7 @@
         </p:spPr>
         <p:txBody>
           <a:bodyPr wrap="square">
-            <a:spAutoFit/>
+            <a:noAutofit/>
           </a:bodyPr>
           <a:lstStyle/>
           <a:p>
@@ -3969,7 +3969,7 @@
         <p:spPr>
           <a:xfrm>
             <a:off x="548640" y="2880360"/>
-            <a:ext cx="3474720" cy="1417320"/>
+            <a:ext cx="3749039" cy="1417320"/>
           </a:xfrm>
           <a:prstGeom prst="roundRect">
             <a:avLst>
@@ -4014,7 +4014,7 @@
         <p:spPr>
           <a:xfrm>
             <a:off x="731520" y="2990088"/>
-            <a:ext cx="3108960" cy="365760"/>
+            <a:ext cx="3383280" cy="365760"/>
           </a:xfrm>
           <a:prstGeom prst="rect">
             <a:avLst/>
@@ -4023,7 +4023,7 @@
         </p:spPr>
         <p:txBody>
           <a:bodyPr wrap="square">
-            <a:spAutoFit/>
+            <a:noAutofit/>
           </a:bodyPr>
           <a:lstStyle/>
           <a:p>
@@ -4039,7 +4039,7 @@
                 </a:solidFill>
                 <a:latin typeface="Calibri"/>
               </a:rPr>
-              <a:t>PR-AUC</a:t>
+              <a:t>PR-AUC: model vs baseline</a:t>
             </a:r>
           </a:p>
         </p:txBody>
@@ -4052,8 +4052,8 @@
         </p:nvSpPr>
         <p:spPr>
           <a:xfrm>
-            <a:off x="731520" y="3291840"/>
-            <a:ext cx="3108960" cy="548640"/>
+            <a:off x="731520" y="3310128"/>
+            <a:ext cx="3383280" cy="502920"/>
           </a:xfrm>
           <a:prstGeom prst="rect">
             <a:avLst/>
@@ -4061,8 +4061,8 @@
           <a:noFill/>
         </p:spPr>
         <p:txBody>
-          <a:bodyPr wrap="square">
-            <a:spAutoFit/>
+          <a:bodyPr wrap="none">
+            <a:noAutofit/>
           </a:bodyPr>
           <a:lstStyle/>
           <a:p>
@@ -4072,7 +4072,7 @@
               </a:spcAft>
             </a:pPr>
             <a:r>
-              <a:rPr sz="2400" b="1">
+              <a:rPr sz="2200" b="1">
                 <a:solidFill>
                   <a:srgbClr val="C25B12"/>
                 </a:solidFill>
@@ -4081,31 +4081,22 @@
               <a:t>[   ]</a:t>
             </a:r>
             <a:r>
-              <a:rPr sz="2400" b="0">
+              <a:rPr sz="2200" b="0">
                 <a:solidFill>
                   <a:srgbClr val="262B33"/>
                 </a:solidFill>
                 <a:latin typeface="Calibri"/>
               </a:rPr>
-              <a:t>  vs </a:t>
-            </a:r>
-            <a:r>
-              <a:rPr sz="2400" b="1">
+              <a:t>  vs  </a:t>
+            </a:r>
+            <a:r>
+              <a:rPr sz="2200" b="1">
                 <a:solidFill>
                   <a:srgbClr val="C25B12"/>
                 </a:solidFill>
                 <a:latin typeface="Calibri"/>
               </a:rPr>
               <a:t>[   ]</a:t>
-            </a:r>
-            <a:r>
-              <a:rPr sz="2400" b="0">
-                <a:solidFill>
-                  <a:srgbClr val="262B33"/>
-                </a:solidFill>
-                <a:latin typeface="Calibri"/>
-              </a:rPr>
-              <a:t> baseline</a:t>
             </a:r>
           </a:p>
         </p:txBody>
@@ -4119,7 +4110,7 @@
         <p:spPr>
           <a:xfrm>
             <a:off x="731520" y="3867912"/>
-            <a:ext cx="3108960" cy="365760"/>
+            <a:ext cx="3383280" cy="365760"/>
           </a:xfrm>
           <a:prstGeom prst="rect">
             <a:avLst/>
@@ -4128,7 +4119,7 @@
         </p:spPr>
         <p:txBody>
           <a:bodyPr wrap="square">
-            <a:spAutoFit/>
+            <a:noAutofit/>
           </a:bodyPr>
           <a:lstStyle/>
           <a:p>
@@ -4158,7 +4149,7 @@
         <p:spPr>
           <a:xfrm>
             <a:off x="548640" y="4480560"/>
-            <a:ext cx="3474720" cy="1417320"/>
+            <a:ext cx="3749039" cy="1417320"/>
           </a:xfrm>
           <a:prstGeom prst="roundRect">
             <a:avLst>
@@ -4203,7 +4194,7 @@
         <p:spPr>
           <a:xfrm>
             <a:off x="731520" y="4590288"/>
-            <a:ext cx="3108960" cy="365760"/>
+            <a:ext cx="3383280" cy="365760"/>
           </a:xfrm>
           <a:prstGeom prst="rect">
             <a:avLst/>
@@ -4212,7 +4203,7 @@
         </p:spPr>
         <p:txBody>
           <a:bodyPr wrap="square">
-            <a:spAutoFit/>
+            <a:noAutofit/>
           </a:bodyPr>
           <a:lstStyle/>
           <a:p>
@@ -4241,8 +4232,8 @@
         </p:nvSpPr>
         <p:spPr>
           <a:xfrm>
-            <a:off x="731520" y="4892040"/>
-            <a:ext cx="3108960" cy="548640"/>
+            <a:off x="731520" y="4910328"/>
+            <a:ext cx="3383280" cy="502920"/>
           </a:xfrm>
           <a:prstGeom prst="rect">
             <a:avLst/>
@@ -4250,8 +4241,8 @@
           <a:noFill/>
         </p:spPr>
         <p:txBody>
-          <a:bodyPr wrap="square">
-            <a:spAutoFit/>
+          <a:bodyPr wrap="none">
+            <a:noAutofit/>
           </a:bodyPr>
           <a:lstStyle/>
           <a:p>
@@ -4261,13 +4252,22 @@
               </a:spcAft>
             </a:pPr>
             <a:r>
-              <a:rPr sz="2400" b="1">
+              <a:rPr sz="2200" b="1">
                 <a:solidFill>
                   <a:srgbClr val="C25B12"/>
                 </a:solidFill>
                 <a:latin typeface="Calibri"/>
               </a:rPr>
-              <a:t>[   ]×</a:t>
+              <a:t>[   ]</a:t>
+            </a:r>
+            <a:r>
+              <a:rPr sz="2200" b="0">
+                <a:solidFill>
+                  <a:srgbClr val="262B33"/>
+                </a:solidFill>
+                <a:latin typeface="Calibri"/>
+              </a:rPr>
+              <a:t> ×</a:t>
             </a:r>
           </a:p>
         </p:txBody>
@@ -4281,7 +4281,7 @@
         <p:spPr>
           <a:xfrm>
             <a:off x="731520" y="5468112"/>
-            <a:ext cx="3108960" cy="365760"/>
+            <a:ext cx="3383280" cy="365760"/>
           </a:xfrm>
           <a:prstGeom prst="rect">
             <a:avLst/>
@@ -4290,7 +4290,7 @@
         </p:spPr>
         <p:txBody>
           <a:bodyPr wrap="square">
-            <a:spAutoFit/>
+            <a:noAutofit/>
           </a:bodyPr>
           <a:lstStyle/>
           <a:p>
@@ -4319,8 +4319,8 @@
         </p:nvSpPr>
         <p:spPr>
           <a:xfrm>
-            <a:off x="4389120" y="1280160"/>
-            <a:ext cx="7223760" cy="4617720"/>
+            <a:off x="4572000" y="1280160"/>
+            <a:ext cx="7040880" cy="4617720"/>
           </a:xfrm>
           <a:prstGeom prst="rect">
             <a:avLst/>
@@ -4442,7 +4442,7 @@
         </p:spPr>
         <p:txBody>
           <a:bodyPr wrap="square">
-            <a:spAutoFit/>
+            <a:noAutofit/>
           </a:bodyPr>
           <a:lstStyle/>
           <a:p>
@@ -4481,7 +4481,7 @@
         </p:spPr>
         <p:txBody>
           <a:bodyPr wrap="square">
-            <a:spAutoFit/>
+            <a:noAutofit/>
           </a:bodyPr>
           <a:lstStyle/>
           <a:p>
@@ -4520,7 +4520,7 @@
         </p:spPr>
         <p:txBody>
           <a:bodyPr wrap="square">
-            <a:spAutoFit/>
+            <a:noAutofit/>
           </a:bodyPr>
           <a:lstStyle/>
           <a:p>
@@ -4550,7 +4550,7 @@
         <p:spPr>
           <a:xfrm>
             <a:off x="548640" y="1280160"/>
-            <a:ext cx="3474720" cy="1417320"/>
+            <a:ext cx="3749039" cy="1417320"/>
           </a:xfrm>
           <a:prstGeom prst="roundRect">
             <a:avLst>
@@ -4595,7 +4595,7 @@
         <p:spPr>
           <a:xfrm>
             <a:off x="731520" y="1389888"/>
-            <a:ext cx="3108960" cy="365760"/>
+            <a:ext cx="3383280" cy="365760"/>
           </a:xfrm>
           <a:prstGeom prst="rect">
             <a:avLst/>
@@ -4604,7 +4604,7 @@
         </p:spPr>
         <p:txBody>
           <a:bodyPr wrap="square">
-            <a:spAutoFit/>
+            <a:noAutofit/>
           </a:bodyPr>
           <a:lstStyle/>
           <a:p>
@@ -4620,7 +4620,7 @@
                 </a:solidFill>
                 <a:latin typeface="Calibri"/>
               </a:rPr>
-              <a:t>Conversions (4,000 contacted)</a:t>
+              <a:t>Conversions: model vs random</a:t>
             </a:r>
           </a:p>
         </p:txBody>
@@ -4633,8 +4633,8 @@
         </p:nvSpPr>
         <p:spPr>
           <a:xfrm>
-            <a:off x="731520" y="1691640"/>
-            <a:ext cx="3108960" cy="548640"/>
+            <a:off x="731520" y="1709928"/>
+            <a:ext cx="3383280" cy="502920"/>
           </a:xfrm>
           <a:prstGeom prst="rect">
             <a:avLst/>
@@ -4642,8 +4642,8 @@
           <a:noFill/>
         </p:spPr>
         <p:txBody>
-          <a:bodyPr wrap="square">
-            <a:spAutoFit/>
+          <a:bodyPr wrap="none">
+            <a:noAutofit/>
           </a:bodyPr>
           <a:lstStyle/>
           <a:p>
@@ -4653,7 +4653,7 @@
               </a:spcAft>
             </a:pPr>
             <a:r>
-              <a:rPr sz="2400" b="1">
+              <a:rPr sz="2200" b="1">
                 <a:solidFill>
                   <a:srgbClr val="C25B12"/>
                 </a:solidFill>
@@ -4662,31 +4662,22 @@
               <a:t>[   ]</a:t>
             </a:r>
             <a:r>
-              <a:rPr sz="2400" b="0">
+              <a:rPr sz="2200" b="0">
                 <a:solidFill>
                   <a:srgbClr val="262B33"/>
                 </a:solidFill>
                 <a:latin typeface="Calibri"/>
               </a:rPr>
-              <a:t>  vs </a:t>
-            </a:r>
-            <a:r>
-              <a:rPr sz="2400" b="1">
+              <a:t>  vs  </a:t>
+            </a:r>
+            <a:r>
+              <a:rPr sz="2200" b="1">
                 <a:solidFill>
                   <a:srgbClr val="C25B12"/>
                 </a:solidFill>
                 <a:latin typeface="Calibri"/>
               </a:rPr>
               <a:t>[   ]</a:t>
-            </a:r>
-            <a:r>
-              <a:rPr sz="2400" b="0">
-                <a:solidFill>
-                  <a:srgbClr val="262B33"/>
-                </a:solidFill>
-                <a:latin typeface="Calibri"/>
-              </a:rPr>
-              <a:t> random</a:t>
             </a:r>
           </a:p>
         </p:txBody>
@@ -4700,7 +4691,7 @@
         <p:spPr>
           <a:xfrm>
             <a:off x="731520" y="2267712"/>
-            <a:ext cx="3108960" cy="365760"/>
+            <a:ext cx="3383280" cy="365760"/>
           </a:xfrm>
           <a:prstGeom prst="rect">
             <a:avLst/>
@@ -4709,7 +4700,7 @@
         </p:spPr>
         <p:txBody>
           <a:bodyPr wrap="square">
-            <a:spAutoFit/>
+            <a:noAutofit/>
           </a:bodyPr>
           <a:lstStyle/>
           <a:p>
@@ -4725,7 +4716,7 @@
                 </a:solidFill>
                 <a:latin typeface="Calibri"/>
               </a:rPr>
-              <a:t>actual Jul–Sep outcomes</a:t>
+              <a:t>4,000 contacted, actual Jul–Sep outcomes</a:t>
             </a:r>
           </a:p>
         </p:txBody>
@@ -4739,7 +4730,7 @@
         <p:spPr>
           <a:xfrm>
             <a:off x="548640" y="2880360"/>
-            <a:ext cx="3474720" cy="1417320"/>
+            <a:ext cx="3749039" cy="1417320"/>
           </a:xfrm>
           <a:prstGeom prst="roundRect">
             <a:avLst>
@@ -4784,7 +4775,7 @@
         <p:spPr>
           <a:xfrm>
             <a:off x="731520" y="2990088"/>
-            <a:ext cx="3108960" cy="365760"/>
+            <a:ext cx="3383280" cy="365760"/>
           </a:xfrm>
           <a:prstGeom prst="rect">
             <a:avLst/>
@@ -4793,7 +4784,7 @@
         </p:spPr>
         <p:txBody>
           <a:bodyPr wrap="square">
-            <a:spAutoFit/>
+            <a:noAutofit/>
           </a:bodyPr>
           <a:lstStyle/>
           <a:p>
@@ -4809,7 +4800,7 @@
                 </a:solidFill>
                 <a:latin typeface="Calibri"/>
               </a:rPr>
-              <a:t>Profit</a:t>
+              <a:t>Profit ($k): model vs random</a:t>
             </a:r>
           </a:p>
         </p:txBody>
@@ -4822,8 +4813,8 @@
         </p:nvSpPr>
         <p:spPr>
           <a:xfrm>
-            <a:off x="731520" y="3291840"/>
-            <a:ext cx="3108960" cy="548640"/>
+            <a:off x="731520" y="3310128"/>
+            <a:ext cx="3383280" cy="502920"/>
           </a:xfrm>
           <a:prstGeom prst="rect">
             <a:avLst/>
@@ -4831,8 +4822,8 @@
           <a:noFill/>
         </p:spPr>
         <p:txBody>
-          <a:bodyPr wrap="square">
-            <a:spAutoFit/>
+          <a:bodyPr wrap="none">
+            <a:noAutofit/>
           </a:bodyPr>
           <a:lstStyle/>
           <a:p>
@@ -4842,31 +4833,31 @@
               </a:spcAft>
             </a:pPr>
             <a:r>
-              <a:rPr sz="2400" b="1">
+              <a:rPr sz="2200" b="1">
                 <a:solidFill>
                   <a:srgbClr val="C25B12"/>
                 </a:solidFill>
                 <a:latin typeface="Calibri"/>
               </a:rPr>
-              <a:t>$[   ]k</a:t>
-            </a:r>
-            <a:r>
-              <a:rPr sz="2400" b="0">
+              <a:t>[   ]</a:t>
+            </a:r>
+            <a:r>
+              <a:rPr sz="2200" b="0">
                 <a:solidFill>
                   <a:srgbClr val="262B33"/>
                 </a:solidFill>
                 <a:latin typeface="Calibri"/>
               </a:rPr>
-              <a:t> vs </a:t>
-            </a:r>
-            <a:r>
-              <a:rPr sz="2400" b="1">
+              <a:t>  vs  </a:t>
+            </a:r>
+            <a:r>
+              <a:rPr sz="2200" b="1">
                 <a:solidFill>
                   <a:srgbClr val="C25B12"/>
                 </a:solidFill>
                 <a:latin typeface="Calibri"/>
               </a:rPr>
-              <a:t>$[   ]k</a:t>
+              <a:t>[   ]</a:t>
             </a:r>
           </a:p>
         </p:txBody>
@@ -4880,7 +4871,7 @@
         <p:spPr>
           <a:xfrm>
             <a:off x="731520" y="3867912"/>
-            <a:ext cx="3108960" cy="365760"/>
+            <a:ext cx="3383280" cy="365760"/>
           </a:xfrm>
           <a:prstGeom prst="rect">
             <a:avLst/>
@@ -4889,7 +4880,7 @@
         </p:spPr>
         <p:txBody>
           <a:bodyPr wrap="square">
-            <a:spAutoFit/>
+            <a:noAutofit/>
           </a:bodyPr>
           <a:lstStyle/>
           <a:p>
@@ -4919,7 +4910,7 @@
         <p:spPr>
           <a:xfrm>
             <a:off x="548640" y="4480560"/>
-            <a:ext cx="3474720" cy="1417320"/>
+            <a:ext cx="3749039" cy="1417320"/>
           </a:xfrm>
           <a:prstGeom prst="roundRect">
             <a:avLst>
@@ -4964,7 +4955,7 @@
         <p:spPr>
           <a:xfrm>
             <a:off x="731520" y="4590288"/>
-            <a:ext cx="3108960" cy="365760"/>
+            <a:ext cx="3383280" cy="365760"/>
           </a:xfrm>
           <a:prstGeom prst="rect">
             <a:avLst/>
@@ -4973,7 +4964,7 @@
         </p:spPr>
         <p:txBody>
           <a:bodyPr wrap="square">
-            <a:spAutoFit/>
+            <a:noAutofit/>
           </a:bodyPr>
           <a:lstStyle/>
           <a:p>
@@ -4989,7 +4980,7 @@
                 </a:solidFill>
                 <a:latin typeface="Calibri"/>
               </a:rPr>
-              <a:t>Conversion rate</a:t>
+              <a:t>Conversion rate (%)</a:t>
             </a:r>
           </a:p>
         </p:txBody>
@@ -5002,8 +4993,8 @@
         </p:nvSpPr>
         <p:spPr>
           <a:xfrm>
-            <a:off x="731520" y="4892040"/>
-            <a:ext cx="3108960" cy="548640"/>
+            <a:off x="731520" y="4910328"/>
+            <a:ext cx="3383280" cy="502920"/>
           </a:xfrm>
           <a:prstGeom prst="rect">
             <a:avLst/>
@@ -5011,8 +5002,8 @@
           <a:noFill/>
         </p:spPr>
         <p:txBody>
-          <a:bodyPr wrap="square">
-            <a:spAutoFit/>
+          <a:bodyPr wrap="none">
+            <a:noAutofit/>
           </a:bodyPr>
           <a:lstStyle/>
           <a:p>
@@ -5022,31 +5013,31 @@
               </a:spcAft>
             </a:pPr>
             <a:r>
-              <a:rPr sz="2400" b="1">
+              <a:rPr sz="2200" b="1">
                 <a:solidFill>
                   <a:srgbClr val="C25B12"/>
                 </a:solidFill>
                 <a:latin typeface="Calibri"/>
               </a:rPr>
-              <a:t>[   ]%</a:t>
-            </a:r>
-            <a:r>
-              <a:rPr sz="2400" b="0">
+              <a:t>[   ]</a:t>
+            </a:r>
+            <a:r>
+              <a:rPr sz="2200" b="0">
                 <a:solidFill>
                   <a:srgbClr val="262B33"/>
                 </a:solidFill>
                 <a:latin typeface="Calibri"/>
               </a:rPr>
-              <a:t> vs </a:t>
-            </a:r>
-            <a:r>
-              <a:rPr sz="2400" b="1">
+              <a:t>  vs  </a:t>
+            </a:r>
+            <a:r>
+              <a:rPr sz="2200" b="1">
                 <a:solidFill>
                   <a:srgbClr val="C25B12"/>
                 </a:solidFill>
                 <a:latin typeface="Calibri"/>
               </a:rPr>
-              <a:t>[   ]%</a:t>
+              <a:t>[   ]</a:t>
             </a:r>
           </a:p>
         </p:txBody>
@@ -5060,7 +5051,7 @@
         <p:spPr>
           <a:xfrm>
             <a:off x="731520" y="5468112"/>
-            <a:ext cx="3108960" cy="365760"/>
+            <a:ext cx="3383280" cy="365760"/>
           </a:xfrm>
           <a:prstGeom prst="rect">
             <a:avLst/>
@@ -5069,7 +5060,7 @@
         </p:spPr>
         <p:txBody>
           <a:bodyPr wrap="square">
-            <a:spAutoFit/>
+            <a:noAutofit/>
           </a:bodyPr>
           <a:lstStyle/>
           <a:p>
@@ -5098,8 +5089,8 @@
         </p:nvSpPr>
         <p:spPr>
           <a:xfrm>
-            <a:off x="4389120" y="1234440"/>
-            <a:ext cx="7223760" cy="457200"/>
+            <a:off x="4572000" y="1234440"/>
+            <a:ext cx="7040880" cy="457200"/>
           </a:xfrm>
           <a:prstGeom prst="rect">
             <a:avLst/>
@@ -5108,7 +5099,7 @@
         </p:spPr>
         <p:txBody>
           <a:bodyPr wrap="square">
-            <a:spAutoFit/>
+            <a:noAutofit/>
           </a:bodyPr>
           <a:lstStyle/>
           <a:p>
@@ -5124,7 +5115,7 @@
                 </a:solidFill>
                 <a:latin typeface="Calibri"/>
               </a:rPr>
-              <a:t>What drives purchase</a:t>
+              <a:t>What drives purchase (SHAP)</a:t>
             </a:r>
           </a:p>
         </p:txBody>
@@ -5137,8 +5128,8 @@
         </p:nvSpPr>
         <p:spPr>
           <a:xfrm>
-            <a:off x="4389120" y="1691640"/>
-            <a:ext cx="7223760" cy="2194560"/>
+            <a:off x="4572000" y="1691640"/>
+            <a:ext cx="7040880" cy="2194560"/>
           </a:xfrm>
           <a:prstGeom prst="rect">
             <a:avLst/>
@@ -5147,7 +5138,7 @@
         </p:spPr>
         <p:txBody>
           <a:bodyPr wrap="square">
-            <a:spAutoFit/>
+            <a:noAutofit/>
           </a:bodyPr>
           <a:lstStyle/>
           <a:p>
@@ -5166,13 +5157,13 @@
               <a:t>•  </a:t>
             </a:r>
             <a:r>
-              <a:rPr sz="1600" b="1">
-                <a:solidFill>
-                  <a:srgbClr val="C25B12"/>
-                </a:solidFill>
-                <a:latin typeface="Calibri"/>
-              </a:rPr>
-              <a:t>[Driver 1 from SHAP]</a:t>
+              <a:rPr sz="1600" b="0">
+                <a:solidFill>
+                  <a:srgbClr val="262B33"/>
+                </a:solidFill>
+                <a:latin typeface="Calibri"/>
+              </a:rPr>
+              <a:t>Engaged customers: high email open rate and frequent app logins</a:t>
             </a:r>
           </a:p>
           <a:p>
@@ -5191,13 +5182,13 @@
               <a:t>•  </a:t>
             </a:r>
             <a:r>
-              <a:rPr sz="1600" b="1">
-                <a:solidFill>
-                  <a:srgbClr val="C25B12"/>
-                </a:solidFill>
-                <a:latin typeface="Calibri"/>
-              </a:rPr>
-              <a:t>[Driver 2 from SHAP]</a:t>
+              <a:rPr sz="1600" b="0">
+                <a:solidFill>
+                  <a:srgbClr val="262B33"/>
+                </a:solidFill>
+                <a:latin typeface="Calibri"/>
+              </a:rPr>
+              <a:t>Established relationship: 2–3 products, 1–5 years tenure, late-30s peak</a:t>
             </a:r>
           </a:p>
           <a:p>
@@ -5216,13 +5207,13 @@
               <a:t>•  </a:t>
             </a:r>
             <a:r>
-              <a:rPr sz="1600" b="1">
-                <a:solidFill>
-                  <a:srgbClr val="C25B12"/>
-                </a:solidFill>
-                <a:latin typeface="Calibri"/>
-              </a:rPr>
-              <a:t>[Driver 3 from SHAP]</a:t>
+              <a:rPr sz="1600" b="0">
+                <a:solidFill>
+                  <a:srgbClr val="262B33"/>
+                </a:solidFill>
+                <a:latin typeface="Calibri"/>
+              </a:rPr>
+              <a:t>Timing and care: no product opened in the last 6 months, few complaints</a:t>
             </a:r>
           </a:p>
         </p:txBody>
@@ -5235,8 +5226,8 @@
         </p:nvSpPr>
         <p:spPr>
           <a:xfrm>
-            <a:off x="4389120" y="3840480"/>
-            <a:ext cx="7223760" cy="457200"/>
+            <a:off x="4572000" y="3840480"/>
+            <a:ext cx="7040880" cy="457200"/>
           </a:xfrm>
           <a:prstGeom prst="rect">
             <a:avLst/>
@@ -5245,7 +5236,7 @@
         </p:spPr>
         <p:txBody>
           <a:bodyPr wrap="square">
-            <a:spAutoFit/>
+            <a:noAutofit/>
           </a:bodyPr>
           <a:lstStyle/>
           <a:p>
@@ -5274,8 +5265,8 @@
         </p:nvSpPr>
         <p:spPr>
           <a:xfrm>
-            <a:off x="4389120" y="4297680"/>
-            <a:ext cx="7223760" cy="2011680"/>
+            <a:off x="4572000" y="4297680"/>
+            <a:ext cx="7040880" cy="2011680"/>
           </a:xfrm>
           <a:prstGeom prst="rect">
             <a:avLst/>
@@ -5284,7 +5275,7 @@
         </p:spPr>
         <p:txBody>
           <a:bodyPr wrap="square">
-            <a:spAutoFit/>
+            <a:noAutofit/>
           </a:bodyPr>
           <a:lstStyle/>
           <a:p>

</xml_diff>